<commit_message>
fix(defensa): presentacion, guion, libreto y folleto presentan los efectos con el requisito como unidad, pequenos, y la URL del nuevo propietario
</commit_message>
<xml_diff>
--- a/08_Defensa/presentacion.pptx
+++ b/08_Defensa/presentacion.pptx
@@ -5,7 +5,7 @@
     <p:sldMasterId id="2147483648" r:id="rId1"/>
   </p:sldMasterIdLst>
   <p:notesMasterIdLst>
-    <p:notesMasterId r:id="rId14"/>
+    <p:notesMasterId r:id="rId17"/>
   </p:notesMasterIdLst>
   <p:sldIdLst>
     <p:sldId id="256" r:id="rId2"/>
@@ -18,11 +18,11 @@
     <p:sldId id="264" r:id="rId9"/>
     <p:sldId id="265" r:id="rId10"/>
     <p:sldId id="266" r:id="rId11"/>
-    <p:sldId id="269" r:id="rId19"/>
-    <p:sldId id="270" r:id="rId20"/>
-    <p:sldId id="271" r:id="rId21"/>
-    <p:sldId id="267" r:id="rId12"/>
-    <p:sldId id="268" r:id="rId13"/>
+    <p:sldId id="269" r:id="rId12"/>
+    <p:sldId id="270" r:id="rId13"/>
+    <p:sldId id="271" r:id="rId14"/>
+    <p:sldId id="267" r:id="rId15"/>
+    <p:sldId id="268" r:id="rId16"/>
   </p:sldIdLst>
   <p:sldSz cx="12192000" cy="6858000"/>
   <p:notesSz cx="6858000" cy="12192000"/>
@@ -488,7 +488,7 @@
           <a:p>
             <a:fld id="{F7021451-1387-4CA6-816F-3879F97B5CBC}" type="slidenum">
               <a:rPr lang="en-US"/>
-              <a:t>11</a:t>
+              <a:t>14</a:t>
             </a:fld>
             <a:endParaRPr lang="en-US"/>
           </a:p>
@@ -574,7 +574,7 @@
           <a:p>
             <a:fld id="{F7021451-1387-4CA6-816F-3879F97B5CBC}" type="slidenum">
               <a:rPr lang="en-US"/>
-              <a:t>12</a:t>
+              <a:t>15</a:t>
             </a:fld>
             <a:endParaRPr lang="en-US"/>
           </a:p>
@@ -2571,7 +2571,7 @@
 </file>
 
 <file path=ppt/slides/slide11.xml><?xml version="1.0" encoding="utf-8"?>
-<p:sld xmlns:a="http://schemas.openxmlformats.org/drawingml/2006/main" xmlns:p="http://schemas.openxmlformats.org/presentationml/2006/main" xmlns:r="http://schemas.openxmlformats.org/officeDocument/2006/relationships">
+<p:sld xmlns:a="http://schemas.openxmlformats.org/drawingml/2006/main" xmlns:r="http://schemas.openxmlformats.org/officeDocument/2006/relationships" xmlns:p="http://schemas.openxmlformats.org/presentationml/2006/main">
   <p:cSld>
     <p:spTree>
       <p:nvGrpSpPr>
@@ -2579,7 +2579,14 @@
         <p:cNvGrpSpPr/>
         <p:nvPr/>
       </p:nvGrpSpPr>
-      <p:grpSpPr/>
+      <p:grpSpPr>
+        <a:xfrm>
+          <a:off x="0" y="0"/>
+          <a:ext cx="0" cy="0"/>
+          <a:chOff x="0" y="0"/>
+          <a:chExt cx="0" cy="0"/>
+        </a:xfrm>
+      </p:grpSpPr>
       <p:sp>
         <p:nvSpPr>
           <p:cNvPr id="2" name="TextBox 1"/>
@@ -2963,7 +2970,7 @@
 </file>
 
 <file path=ppt/slides/slide12.xml><?xml version="1.0" encoding="utf-8"?>
-<p:sld xmlns:a="http://schemas.openxmlformats.org/drawingml/2006/main" xmlns:p="http://schemas.openxmlformats.org/presentationml/2006/main" xmlns:r="http://schemas.openxmlformats.org/officeDocument/2006/relationships">
+<p:sld xmlns:a="http://schemas.openxmlformats.org/drawingml/2006/main" xmlns:r="http://schemas.openxmlformats.org/officeDocument/2006/relationships" xmlns:p="http://schemas.openxmlformats.org/presentationml/2006/main">
   <p:cSld>
     <p:spTree>
       <p:nvGrpSpPr>
@@ -2971,7 +2978,14 @@
         <p:cNvGrpSpPr/>
         <p:nvPr/>
       </p:nvGrpSpPr>
-      <p:grpSpPr/>
+      <p:grpSpPr>
+        <a:xfrm>
+          <a:off x="0" y="0"/>
+          <a:ext cx="0" cy="0"/>
+          <a:chOff x="0" y="0"/>
+          <a:chExt cx="0" cy="0"/>
+        </a:xfrm>
+      </p:grpSpPr>
       <p:sp>
         <p:nvSpPr>
           <p:cNvPr id="2" name="TextBox 1"/>
@@ -3355,7 +3369,7 @@
 </file>
 
 <file path=ppt/slides/slide13.xml><?xml version="1.0" encoding="utf-8"?>
-<p:sld xmlns:a="http://schemas.openxmlformats.org/drawingml/2006/main" xmlns:p="http://schemas.openxmlformats.org/presentationml/2006/main" xmlns:r="http://schemas.openxmlformats.org/officeDocument/2006/relationships">
+<p:sld xmlns:a="http://schemas.openxmlformats.org/drawingml/2006/main" xmlns:r="http://schemas.openxmlformats.org/officeDocument/2006/relationships" xmlns:p="http://schemas.openxmlformats.org/presentationml/2006/main">
   <p:cSld>
     <p:spTree>
       <p:nvGrpSpPr>
@@ -3363,7 +3377,14 @@
         <p:cNvGrpSpPr/>
         <p:nvPr/>
       </p:nvGrpSpPr>
-      <p:grpSpPr/>
+      <p:grpSpPr>
+        <a:xfrm>
+          <a:off x="0" y="0"/>
+          <a:ext cx="0" cy="0"/>
+          <a:chOff x="0" y="0"/>
+          <a:chExt cx="0" cy="0"/>
+        </a:xfrm>
+      </p:grpSpPr>
       <p:sp>
         <p:nvSpPr>
           <p:cNvPr id="2" name="TextBox 1"/>
@@ -4055,7 +4076,7 @@
       </p:sp>
       <p:sp>
         <p:nvSpPr>
-          <p:cNvPr id="9" name="Shape 7"/>
+          <p:cNvPr id="12" name="Shape 7"/>
           <p:cNvSpPr/>
           <p:nvPr/>
         </p:nvSpPr>
@@ -4113,7 +4134,7 @@
       </p:sp>
       <p:sp>
         <p:nvSpPr>
-          <p:cNvPr id="10" name="Shape 8"/>
+          <p:cNvPr id="13" name="Shape 8"/>
           <p:cNvSpPr/>
           <p:nvPr/>
         </p:nvSpPr>
@@ -4686,7 +4707,18 @@
                 <a:ea typeface="Calibri" pitchFamily="34" charset="-122"/>
                 <a:cs typeface="Calibri" pitchFamily="34" charset="-120"/>
               </a:rPr>
-              <a:t>Repositorio: github.com/gsanchezc6-beep/SIGA_FGMMN_ISR401_AVANCE_2B</a:t>
+              <a:t>Repositorio</a:t>
+            </a:r>
+            <a:r>
+              <a:rPr lang="en-US" sz="1300">
+                <a:solidFill>
+                  <a:srgbClr val="AFC3B8"/>
+                </a:solidFill>
+                <a:latin typeface="Calibri" pitchFamily="34" charset="0"/>
+                <a:ea typeface="Calibri" pitchFamily="34" charset="-122"/>
+                <a:cs typeface="Calibri" pitchFamily="34" charset="-120"/>
+              </a:rPr>
+              <a:t>: github.com/gleiston-guerrero/SIGA_FGMMN_ISR401_AVANCE_2B</a:t>
             </a:r>
             <a:endParaRPr lang="en-US" sz="1300" dirty="0"/>
           </a:p>
@@ -8171,7 +8203,7 @@
               <a:buNone/>
             </a:pPr>
             <a:r>
-              <a:rPr lang="en-US" sz="3200" b="1" dirty="0">
+              <a:rPr lang="es-ES" sz="3200" b="1">
                 <a:solidFill>
                   <a:srgbClr val="1B4332"/>
                 </a:solidFill>
@@ -8179,7 +8211,7 @@
                 <a:ea typeface="Cambria" pitchFamily="34" charset="-122"/>
                 <a:cs typeface="Cambria" pitchFamily="34" charset="-120"/>
               </a:rPr>
-              <a:t>Efectos grandes, intervalos que cruzan el cero</a:t>
+              <a:t>Efectos pequeños, intervalos que cruzan el cero</a:t>
             </a:r>
             <a:endParaRPr lang="en-US" sz="3200" dirty="0"/>
           </a:p>
@@ -8187,9 +8219,15 @@
       </p:sp>
       <p:pic>
         <p:nvPicPr>
-          <p:cNvPr id="4" name="Image 0" descr="C:\Users\Vodruk\Desktop\SIGA_FGMMN_ISR401_AVANCE_2B\07_Publicacion\figuras\fig03_tamanos_efecto.png"/>
+          <p:cNvPr id="15" name="Image 0">
+            <a:extLst>
+              <a:ext uri="{FF2B5EF4-FFF2-40B4-BE49-F238E27FC236}">
+                <a16:creationId xmlns:a16="http://schemas.microsoft.com/office/drawing/2014/main" id="{0692E193-989B-4467-A594-E3D49987947C}"/>
+              </a:ext>
+            </a:extLst>
+          </p:cNvPr>
           <p:cNvPicPr>
-            <a:picLocks noChangeAspect="1"/>
+            <a:picLocks/>
           </p:cNvPicPr>
           <p:nvPr/>
         </p:nvPicPr>
@@ -8448,7 +8486,7 @@
               <a:buNone/>
             </a:pPr>
             <a:r>
-              <a:rPr lang="en-US" sz="1200" i="1" dirty="0">
+              <a:rPr lang="es-ES" sz="1200" i="1">
                 <a:solidFill>
                   <a:srgbClr val="6B7A72"/>
                 </a:solidFill>
@@ -8456,7 +8494,7 @@
                 <a:ea typeface="Calibri" pitchFamily="34" charset="-122"/>
                 <a:cs typeface="Calibri" pitchFamily="34" charset="-120"/>
               </a:rPr>
-              <a:t>Efectos grandes en magnitud, pero los intervalos de confianza al 95 % cruzan el cero: esto es exactamente lo que se espera con una muestra tan pequeña.</a:t>
+              <a:t>Con el requisito como unidad (25 frente a 26), los efectos son pequeños, de −0,12 a −0,26, y todos sus intervalos de confianza al 95 % cruzan el cero.</a:t>
             </a:r>
             <a:endParaRPr lang="en-US" sz="1200" dirty="0"/>
           </a:p>

</xml_diff>

<commit_message>
fix(defensa): las notas del orador de la diapositiva 7 y un comentario del manuscrito dejan de arrastrar lo retirado; caratula, bitacora y manifiesto al dia
</commit_message>
<xml_diff>
--- a/08_Defensa/presentacion.pptx
+++ b/08_Defensa/presentacion.pptx
@@ -1071,7 +1071,11 @@
           <a:lstStyle/>
           <a:p>
             <a:r>
-              <a:t>Mostrar la figura de tamanos de efecto con sus intervalos: grandes en magnitud, pero cruzan el cero. Potencia real con 3 jueces: 8,4 %; harian falta 34 observaciones apareadas para el 80 % convencional. La curva de saturacion NO se menciona aqui: va en la diapositiva 13, y alcanza inflexion en EV-23.</a:t>
+              <a:rPr lang="es-ES"/>
+              <a:t>Mostrar la figura de tamanos de efecto con sus intervalos: con el requisito como unidad (25 frente a 26) son pequenos, de −0,12 a −0,26, y todos cruzan el cero.</a:t>
+            </a:r>
+            <a:r>
+              <a:t> Potencia real con 3 jueces: 8,4 %; harian falta 34 observaciones apareadas para el 80 % convencional. La curva de saturacion NO se menciona aqui: va en la diapositiva 13, y alcanza inflexion en EV-23.</a:t>
             </a:r>
           </a:p>
         </p:txBody>

</xml_diff>